<commit_message>
Fix PNCC_0 blank histogram
</commit_message>
<xml_diff>
--- a/presentation/MCCNNY_2026_FINAL_v8.pptx
+++ b/presentation/MCCNNY_2026_FINAL_v8.pptx
@@ -1096,9 +1096,16 @@
               <a:t>[30 seconds]</a:t>
             </a:r>
           </a:p>
-          <a:p>
-            <a:r>
-              <a:t>"Before testing, we check the data shape. Most features are near bell-shaped — 34 out of 36. This means standard statistical tests are valid. For the two that aren't, we use rank-based tests."</a:t>
+          <a:p/>
+          <a:p>
+            <a:r>
+              <a:t>"Before running statistical tests, we check what the data looks like. These histograms show 8 representative features — one from each group. Most are close to bell-shaped — 34 out of 36 are near-normal. That means standard statistical tests are valid."</a:t>
+            </a:r>
+          </a:p>
+          <a:p/>
+          <a:p>
+            <a:r>
+              <a:t>"Note: PNCC coefficient 0 is a constant (6.325 for every file) due to the DCT normalization. It carries zero information — AUC is exactly 0.5. We show PNCC_10 instead, which is the most discriminative PNCC feature at AUC 0.633."</a:t>
             </a:r>
           </a:p>
           <a:p>
@@ -7434,16 +7441,364 @@
           </a:p>
         </p:txBody>
       </p:sp>
+      <p:sp>
+        <p:nvSpPr>
+          <p:cNvPr id="4" name="TextBox 3"/>
+          <p:cNvSpPr txBox="1"/>
+          <p:nvPr/>
+        </p:nvSpPr>
+        <p:spPr>
+          <a:xfrm>
+            <a:off x="8412480" y="731520"/>
+            <a:ext cx="3474720" cy="365760"/>
+          </a:xfrm>
+          <a:prstGeom prst="rect">
+            <a:avLst/>
+          </a:prstGeom>
+          <a:noFill/>
+        </p:spPr>
+        <p:txBody>
+          <a:bodyPr wrap="square">
+            <a:spAutoFit/>
+          </a:bodyPr>
+          <a:lstStyle/>
+          <a:p>
+            <a:pPr algn="l">
+              <a:defRPr sz="1800" b="1">
+                <a:solidFill>
+                  <a:srgbClr val="F39C12"/>
+                </a:solidFill>
+                <a:latin typeface="Calibri"/>
+              </a:defRPr>
+            </a:pPr>
+            <a:r>
+              <a:t>Distribution Check</a:t>
+            </a:r>
+          </a:p>
+        </p:txBody>
+      </p:sp>
+      <p:sp>
+        <p:nvSpPr>
+          <p:cNvPr id="5" name="TextBox 4"/>
+          <p:cNvSpPr txBox="1"/>
+          <p:nvPr/>
+        </p:nvSpPr>
+        <p:spPr>
+          <a:xfrm>
+            <a:off x="8412480" y="1188720"/>
+            <a:ext cx="3474720" cy="5029200"/>
+          </a:xfrm>
+          <a:prstGeom prst="rect">
+            <a:avLst/>
+          </a:prstGeom>
+          <a:noFill/>
+        </p:spPr>
+        <p:txBody>
+          <a:bodyPr wrap="square">
+            <a:spAutoFit/>
+          </a:bodyPr>
+          <a:lstStyle/>
+          <a:p>
+            <a:pPr>
+              <a:spcAft>
+                <a:spcPts val="300"/>
+              </a:spcAft>
+              <a:defRPr sz="1100">
+                <a:solidFill>
+                  <a:srgbClr val="CCCCCC"/>
+                </a:solidFill>
+                <a:latin typeface="Calibri"/>
+              </a:defRPr>
+            </a:pPr>
+            <a:r>
+              <a:t>Before choosing statistical tests,</a:t>
+            </a:r>
+          </a:p>
+          <a:p>
+            <a:pPr>
+              <a:spcAft>
+                <a:spcPts val="300"/>
+              </a:spcAft>
+              <a:defRPr sz="1100">
+                <a:solidFill>
+                  <a:srgbClr val="CCCCCC"/>
+                </a:solidFill>
+                <a:latin typeface="Calibri"/>
+              </a:defRPr>
+            </a:pPr>
+            <a:r>
+              <a:t>we check if data is bell-shaped</a:t>
+            </a:r>
+          </a:p>
+          <a:p>
+            <a:pPr>
+              <a:spcAft>
+                <a:spcPts val="300"/>
+              </a:spcAft>
+              <a:defRPr sz="1100">
+                <a:solidFill>
+                  <a:srgbClr val="CCCCCC"/>
+                </a:solidFill>
+                <a:latin typeface="Calibri"/>
+              </a:defRPr>
+            </a:pPr>
+            <a:r>
+              <a:t>(normally distributed).</a:t>
+            </a:r>
+          </a:p>
+          <a:p>
+            <a:pPr>
+              <a:spcAft>
+                <a:spcPts val="300"/>
+              </a:spcAft>
+              <a:defRPr sz="1100">
+                <a:solidFill>
+                  <a:srgbClr val="CCCCCC"/>
+                </a:solidFill>
+                <a:latin typeface="Calibri"/>
+              </a:defRPr>
+            </a:pPr>
+          </a:p>
+          <a:p>
+            <a:pPr>
+              <a:spcAft>
+                <a:spcPts val="300"/>
+              </a:spcAft>
+              <a:defRPr sz="1100">
+                <a:solidFill>
+                  <a:srgbClr val="CCCCCC"/>
+                </a:solidFill>
+                <a:latin typeface="Calibri"/>
+              </a:defRPr>
+            </a:pPr>
+            <a:r>
+              <a:t>Skewness: is it lopsided?</a:t>
+            </a:r>
+          </a:p>
+          <a:p>
+            <a:pPr>
+              <a:spcAft>
+                <a:spcPts val="300"/>
+              </a:spcAft>
+              <a:defRPr sz="1100">
+                <a:solidFill>
+                  <a:srgbClr val="CCCCCC"/>
+                </a:solidFill>
+                <a:latin typeface="Calibri"/>
+              </a:defRPr>
+            </a:pPr>
+            <a:r>
+              <a:t>  • |skew| &lt; 1 = okay</a:t>
+            </a:r>
+          </a:p>
+          <a:p>
+            <a:pPr>
+              <a:spcAft>
+                <a:spcPts val="300"/>
+              </a:spcAft>
+              <a:defRPr sz="1100">
+                <a:solidFill>
+                  <a:srgbClr val="CCCCCC"/>
+                </a:solidFill>
+                <a:latin typeface="Calibri"/>
+              </a:defRPr>
+            </a:pPr>
+          </a:p>
+          <a:p>
+            <a:pPr>
+              <a:spcAft>
+                <a:spcPts val="300"/>
+              </a:spcAft>
+              <a:defRPr sz="1100">
+                <a:solidFill>
+                  <a:srgbClr val="CCCCCC"/>
+                </a:solidFill>
+                <a:latin typeface="Calibri"/>
+              </a:defRPr>
+            </a:pPr>
+            <a:r>
+              <a:t>Kurtosis: heavy tails?</a:t>
+            </a:r>
+          </a:p>
+          <a:p>
+            <a:pPr>
+              <a:spcAft>
+                <a:spcPts val="300"/>
+              </a:spcAft>
+              <a:defRPr sz="1100">
+                <a:solidFill>
+                  <a:srgbClr val="CCCCCC"/>
+                </a:solidFill>
+                <a:latin typeface="Calibri"/>
+              </a:defRPr>
+            </a:pPr>
+            <a:r>
+              <a:t>  • |kurt| &lt; 3 = okay</a:t>
+            </a:r>
+          </a:p>
+          <a:p>
+            <a:pPr>
+              <a:spcAft>
+                <a:spcPts val="300"/>
+              </a:spcAft>
+              <a:defRPr sz="1100">
+                <a:solidFill>
+                  <a:srgbClr val="CCCCCC"/>
+                </a:solidFill>
+                <a:latin typeface="Calibri"/>
+              </a:defRPr>
+            </a:pPr>
+          </a:p>
+          <a:p>
+            <a:pPr>
+              <a:spcAft>
+                <a:spcPts val="300"/>
+              </a:spcAft>
+              <a:defRPr sz="1100">
+                <a:solidFill>
+                  <a:srgbClr val="CCCCCC"/>
+                </a:solidFill>
+                <a:latin typeface="Calibri"/>
+              </a:defRPr>
+            </a:pPr>
+            <a:r>
+              <a:t>Result: 34 of 36 features</a:t>
+            </a:r>
+          </a:p>
+          <a:p>
+            <a:pPr>
+              <a:spcAft>
+                <a:spcPts val="300"/>
+              </a:spcAft>
+              <a:defRPr sz="1100">
+                <a:solidFill>
+                  <a:srgbClr val="CCCCCC"/>
+                </a:solidFill>
+                <a:latin typeface="Calibri"/>
+              </a:defRPr>
+            </a:pPr>
+            <a:r>
+              <a:t>are near-normal.</a:t>
+            </a:r>
+          </a:p>
+          <a:p>
+            <a:pPr>
+              <a:spcAft>
+                <a:spcPts val="300"/>
+              </a:spcAft>
+              <a:defRPr sz="1100">
+                <a:solidFill>
+                  <a:srgbClr val="CCCCCC"/>
+                </a:solidFill>
+                <a:latin typeface="Calibri"/>
+              </a:defRPr>
+            </a:pPr>
+          </a:p>
+          <a:p>
+            <a:pPr>
+              <a:spcAft>
+                <a:spcPts val="300"/>
+              </a:spcAft>
+              <a:defRPr sz="1100">
+                <a:solidFill>
+                  <a:srgbClr val="CCCCCC"/>
+                </a:solidFill>
+                <a:latin typeface="Calibri"/>
+              </a:defRPr>
+            </a:pPr>
+            <a:r>
+              <a:t>This means we CAN use</a:t>
+            </a:r>
+          </a:p>
+          <a:p>
+            <a:pPr>
+              <a:spcAft>
+                <a:spcPts val="300"/>
+              </a:spcAft>
+              <a:defRPr sz="1100">
+                <a:solidFill>
+                  <a:srgbClr val="CCCCCC"/>
+                </a:solidFill>
+                <a:latin typeface="Calibri"/>
+              </a:defRPr>
+            </a:pPr>
+            <a:r>
+              <a:t>standard statistical tests</a:t>
+            </a:r>
+          </a:p>
+          <a:p>
+            <a:pPr>
+              <a:spcAft>
+                <a:spcPts val="300"/>
+              </a:spcAft>
+              <a:defRPr sz="1100">
+                <a:solidFill>
+                  <a:srgbClr val="CCCCCC"/>
+                </a:solidFill>
+                <a:latin typeface="Calibri"/>
+              </a:defRPr>
+            </a:pPr>
+            <a:r>
+              <a:t>(t-test, correlation, etc.)</a:t>
+            </a:r>
+          </a:p>
+          <a:p>
+            <a:pPr>
+              <a:spcAft>
+                <a:spcPts val="300"/>
+              </a:spcAft>
+              <a:defRPr sz="1100">
+                <a:solidFill>
+                  <a:srgbClr val="CCCCCC"/>
+                </a:solidFill>
+                <a:latin typeface="Calibri"/>
+              </a:defRPr>
+            </a:pPr>
+          </a:p>
+          <a:p>
+            <a:pPr>
+              <a:spcAft>
+                <a:spcPts val="300"/>
+              </a:spcAft>
+              <a:defRPr sz="1100">
+                <a:solidFill>
+                  <a:srgbClr val="CCCCCC"/>
+                </a:solidFill>
+                <a:latin typeface="Calibri"/>
+              </a:defRPr>
+            </a:pPr>
+            <a:r>
+              <a:t>For the 2 non-normal features,</a:t>
+            </a:r>
+          </a:p>
+          <a:p>
+            <a:pPr>
+              <a:spcAft>
+                <a:spcPts val="300"/>
+              </a:spcAft>
+              <a:defRPr sz="1100">
+                <a:solidFill>
+                  <a:srgbClr val="CCCCCC"/>
+                </a:solidFill>
+                <a:latin typeface="Calibri"/>
+              </a:defRPr>
+            </a:pPr>
+            <a:r>
+              <a:t>we use rank-based tests.</a:t>
+            </a:r>
+          </a:p>
+        </p:txBody>
+      </p:sp>
       <p:pic>
         <p:nvPicPr>
-          <p:cNvPr id="3" name="Picture 2" descr="fig7_distribution_shapes.png"/>
+          <p:cNvPr id="6" name="Picture 5" descr="fig7_distribution_shapes.png"/>
           <p:cNvPicPr>
             <a:picLocks noChangeAspect="1"/>
           </p:cNvPicPr>
           <p:nvPr/>
         </p:nvPicPr>
         <p:blipFill>
-          <a:blip r:embed="rId2"/>
+          <a:blip r:embed="rId4"/>
           <a:stretch>
             <a:fillRect/>
           </a:stretch>
@@ -7458,354 +7813,6 @@
           </a:prstGeom>
         </p:spPr>
       </p:pic>
-      <p:sp>
-        <p:nvSpPr>
-          <p:cNvPr id="4" name="TextBox 3"/>
-          <p:cNvSpPr txBox="1"/>
-          <p:nvPr/>
-        </p:nvSpPr>
-        <p:spPr>
-          <a:xfrm>
-            <a:off x="8412480" y="731520"/>
-            <a:ext cx="3474720" cy="365760"/>
-          </a:xfrm>
-          <a:prstGeom prst="rect">
-            <a:avLst/>
-          </a:prstGeom>
-          <a:noFill/>
-        </p:spPr>
-        <p:txBody>
-          <a:bodyPr wrap="square">
-            <a:spAutoFit/>
-          </a:bodyPr>
-          <a:lstStyle/>
-          <a:p>
-            <a:pPr algn="l">
-              <a:defRPr sz="1800" b="1">
-                <a:solidFill>
-                  <a:srgbClr val="F39C12"/>
-                </a:solidFill>
-                <a:latin typeface="Calibri"/>
-              </a:defRPr>
-            </a:pPr>
-            <a:r>
-              <a:t>Distribution Check</a:t>
-            </a:r>
-          </a:p>
-        </p:txBody>
-      </p:sp>
-      <p:sp>
-        <p:nvSpPr>
-          <p:cNvPr id="5" name="TextBox 4"/>
-          <p:cNvSpPr txBox="1"/>
-          <p:nvPr/>
-        </p:nvSpPr>
-        <p:spPr>
-          <a:xfrm>
-            <a:off x="8412480" y="1188720"/>
-            <a:ext cx="3474720" cy="5029200"/>
-          </a:xfrm>
-          <a:prstGeom prst="rect">
-            <a:avLst/>
-          </a:prstGeom>
-          <a:noFill/>
-        </p:spPr>
-        <p:txBody>
-          <a:bodyPr wrap="square">
-            <a:spAutoFit/>
-          </a:bodyPr>
-          <a:lstStyle/>
-          <a:p>
-            <a:pPr>
-              <a:spcAft>
-                <a:spcPts val="300"/>
-              </a:spcAft>
-              <a:defRPr sz="1100">
-                <a:solidFill>
-                  <a:srgbClr val="CCCCCC"/>
-                </a:solidFill>
-                <a:latin typeface="Calibri"/>
-              </a:defRPr>
-            </a:pPr>
-            <a:r>
-              <a:t>Before choosing statistical tests,</a:t>
-            </a:r>
-          </a:p>
-          <a:p>
-            <a:pPr>
-              <a:spcAft>
-                <a:spcPts val="300"/>
-              </a:spcAft>
-              <a:defRPr sz="1100">
-                <a:solidFill>
-                  <a:srgbClr val="CCCCCC"/>
-                </a:solidFill>
-                <a:latin typeface="Calibri"/>
-              </a:defRPr>
-            </a:pPr>
-            <a:r>
-              <a:t>we check if data is bell-shaped</a:t>
-            </a:r>
-          </a:p>
-          <a:p>
-            <a:pPr>
-              <a:spcAft>
-                <a:spcPts val="300"/>
-              </a:spcAft>
-              <a:defRPr sz="1100">
-                <a:solidFill>
-                  <a:srgbClr val="CCCCCC"/>
-                </a:solidFill>
-                <a:latin typeface="Calibri"/>
-              </a:defRPr>
-            </a:pPr>
-            <a:r>
-              <a:t>(normally distributed).</a:t>
-            </a:r>
-          </a:p>
-          <a:p>
-            <a:pPr>
-              <a:spcAft>
-                <a:spcPts val="300"/>
-              </a:spcAft>
-              <a:defRPr sz="1100">
-                <a:solidFill>
-                  <a:srgbClr val="CCCCCC"/>
-                </a:solidFill>
-                <a:latin typeface="Calibri"/>
-              </a:defRPr>
-            </a:pPr>
-          </a:p>
-          <a:p>
-            <a:pPr>
-              <a:spcAft>
-                <a:spcPts val="300"/>
-              </a:spcAft>
-              <a:defRPr sz="1100">
-                <a:solidFill>
-                  <a:srgbClr val="CCCCCC"/>
-                </a:solidFill>
-                <a:latin typeface="Calibri"/>
-              </a:defRPr>
-            </a:pPr>
-            <a:r>
-              <a:t>Skewness: is it lopsided?</a:t>
-            </a:r>
-          </a:p>
-          <a:p>
-            <a:pPr>
-              <a:spcAft>
-                <a:spcPts val="300"/>
-              </a:spcAft>
-              <a:defRPr sz="1100">
-                <a:solidFill>
-                  <a:srgbClr val="CCCCCC"/>
-                </a:solidFill>
-                <a:latin typeface="Calibri"/>
-              </a:defRPr>
-            </a:pPr>
-            <a:r>
-              <a:t>  • |skew| &lt; 1 = okay</a:t>
-            </a:r>
-          </a:p>
-          <a:p>
-            <a:pPr>
-              <a:spcAft>
-                <a:spcPts val="300"/>
-              </a:spcAft>
-              <a:defRPr sz="1100">
-                <a:solidFill>
-                  <a:srgbClr val="CCCCCC"/>
-                </a:solidFill>
-                <a:latin typeface="Calibri"/>
-              </a:defRPr>
-            </a:pPr>
-          </a:p>
-          <a:p>
-            <a:pPr>
-              <a:spcAft>
-                <a:spcPts val="300"/>
-              </a:spcAft>
-              <a:defRPr sz="1100">
-                <a:solidFill>
-                  <a:srgbClr val="CCCCCC"/>
-                </a:solidFill>
-                <a:latin typeface="Calibri"/>
-              </a:defRPr>
-            </a:pPr>
-            <a:r>
-              <a:t>Kurtosis: heavy tails?</a:t>
-            </a:r>
-          </a:p>
-          <a:p>
-            <a:pPr>
-              <a:spcAft>
-                <a:spcPts val="300"/>
-              </a:spcAft>
-              <a:defRPr sz="1100">
-                <a:solidFill>
-                  <a:srgbClr val="CCCCCC"/>
-                </a:solidFill>
-                <a:latin typeface="Calibri"/>
-              </a:defRPr>
-            </a:pPr>
-            <a:r>
-              <a:t>  • |kurt| &lt; 3 = okay</a:t>
-            </a:r>
-          </a:p>
-          <a:p>
-            <a:pPr>
-              <a:spcAft>
-                <a:spcPts val="300"/>
-              </a:spcAft>
-              <a:defRPr sz="1100">
-                <a:solidFill>
-                  <a:srgbClr val="CCCCCC"/>
-                </a:solidFill>
-                <a:latin typeface="Calibri"/>
-              </a:defRPr>
-            </a:pPr>
-          </a:p>
-          <a:p>
-            <a:pPr>
-              <a:spcAft>
-                <a:spcPts val="300"/>
-              </a:spcAft>
-              <a:defRPr sz="1100">
-                <a:solidFill>
-                  <a:srgbClr val="CCCCCC"/>
-                </a:solidFill>
-                <a:latin typeface="Calibri"/>
-              </a:defRPr>
-            </a:pPr>
-            <a:r>
-              <a:t>Result: 34 of 36 features</a:t>
-            </a:r>
-          </a:p>
-          <a:p>
-            <a:pPr>
-              <a:spcAft>
-                <a:spcPts val="300"/>
-              </a:spcAft>
-              <a:defRPr sz="1100">
-                <a:solidFill>
-                  <a:srgbClr val="CCCCCC"/>
-                </a:solidFill>
-                <a:latin typeface="Calibri"/>
-              </a:defRPr>
-            </a:pPr>
-            <a:r>
-              <a:t>are near-normal.</a:t>
-            </a:r>
-          </a:p>
-          <a:p>
-            <a:pPr>
-              <a:spcAft>
-                <a:spcPts val="300"/>
-              </a:spcAft>
-              <a:defRPr sz="1100">
-                <a:solidFill>
-                  <a:srgbClr val="CCCCCC"/>
-                </a:solidFill>
-                <a:latin typeface="Calibri"/>
-              </a:defRPr>
-            </a:pPr>
-          </a:p>
-          <a:p>
-            <a:pPr>
-              <a:spcAft>
-                <a:spcPts val="300"/>
-              </a:spcAft>
-              <a:defRPr sz="1100">
-                <a:solidFill>
-                  <a:srgbClr val="CCCCCC"/>
-                </a:solidFill>
-                <a:latin typeface="Calibri"/>
-              </a:defRPr>
-            </a:pPr>
-            <a:r>
-              <a:t>This means we CAN use</a:t>
-            </a:r>
-          </a:p>
-          <a:p>
-            <a:pPr>
-              <a:spcAft>
-                <a:spcPts val="300"/>
-              </a:spcAft>
-              <a:defRPr sz="1100">
-                <a:solidFill>
-                  <a:srgbClr val="CCCCCC"/>
-                </a:solidFill>
-                <a:latin typeface="Calibri"/>
-              </a:defRPr>
-            </a:pPr>
-            <a:r>
-              <a:t>standard statistical tests</a:t>
-            </a:r>
-          </a:p>
-          <a:p>
-            <a:pPr>
-              <a:spcAft>
-                <a:spcPts val="300"/>
-              </a:spcAft>
-              <a:defRPr sz="1100">
-                <a:solidFill>
-                  <a:srgbClr val="CCCCCC"/>
-                </a:solidFill>
-                <a:latin typeface="Calibri"/>
-              </a:defRPr>
-            </a:pPr>
-            <a:r>
-              <a:t>(t-test, correlation, etc.)</a:t>
-            </a:r>
-          </a:p>
-          <a:p>
-            <a:pPr>
-              <a:spcAft>
-                <a:spcPts val="300"/>
-              </a:spcAft>
-              <a:defRPr sz="1100">
-                <a:solidFill>
-                  <a:srgbClr val="CCCCCC"/>
-                </a:solidFill>
-                <a:latin typeface="Calibri"/>
-              </a:defRPr>
-            </a:pPr>
-          </a:p>
-          <a:p>
-            <a:pPr>
-              <a:spcAft>
-                <a:spcPts val="300"/>
-              </a:spcAft>
-              <a:defRPr sz="1100">
-                <a:solidFill>
-                  <a:srgbClr val="CCCCCC"/>
-                </a:solidFill>
-                <a:latin typeface="Calibri"/>
-              </a:defRPr>
-            </a:pPr>
-            <a:r>
-              <a:t>For the 2 non-normal features,</a:t>
-            </a:r>
-          </a:p>
-          <a:p>
-            <a:pPr>
-              <a:spcAft>
-                <a:spcPts val="300"/>
-              </a:spcAft>
-              <a:defRPr sz="1100">
-                <a:solidFill>
-                  <a:srgbClr val="CCCCCC"/>
-                </a:solidFill>
-                <a:latin typeface="Calibri"/>
-              </a:defRPr>
-            </a:pPr>
-            <a:r>
-              <a:t>we use rank-based tests.</a:t>
-            </a:r>
-          </a:p>
-        </p:txBody>
-      </p:sp>
     </p:spTree>
   </p:cSld>
   <p:clrMapOvr>

</xml_diff>